<commit_message>
add tableau link in the report
</commit_message>
<xml_diff>
--- a/Report/Global Hotels and Resorts - Cancellation Analysis.pptx
+++ b/Report/Global Hotels and Resorts - Cancellation Analysis.pptx
@@ -7971,7 +7971,9 @@
         </p:nvSpPr>
         <p:spPr/>
         <p:txBody>
-          <a:bodyPr/>
+          <a:bodyPr>
+            <a:normAutofit/>
+          </a:bodyPr>
           <a:lstStyle/>
           <a:p>
             <a:pPr>
@@ -8009,6 +8011,20 @@
             </a:endParaRPr>
           </a:p>
           <a:p>
+            <a:pPr lvl="1">
+              <a:lnSpc>
+                <a:spcPct val="150000"/>
+              </a:lnSpc>
+            </a:pPr>
+            <a:r>
+              <a:rPr lang="en-US" altLang="zh-TW" sz="1000" dirty="0">
+                <a:latin typeface="Microsoft JhengHei UI" panose="020B0604030504040204" pitchFamily="34" charset="-120"/>
+                <a:ea typeface="Microsoft JhengHei UI" panose="020B0604030504040204" pitchFamily="34" charset="-120"/>
+              </a:rPr>
+              <a:t>https://public.tableau.com/views/GlobalHotelsandResortsRevenueAnalysis-CancellationAnalysis/CancelTypeRatioAnalysis?:language=en-US&amp;:sid=&amp;:redirect=auth&amp;:display_count=n&amp;:origin=viz_share_link</a:t>
+            </a:r>
+          </a:p>
+          <a:p>
             <a:pPr>
               <a:lnSpc>
                 <a:spcPct val="150000"/>
@@ -8042,6 +8058,20 @@
               <a:latin typeface="Microsoft JhengHei UI" panose="020B0604030504040204" pitchFamily="34" charset="-120"/>
               <a:ea typeface="Microsoft JhengHei UI" panose="020B0604030504040204" pitchFamily="34" charset="-120"/>
             </a:endParaRPr>
+          </a:p>
+          <a:p>
+            <a:pPr lvl="1">
+              <a:lnSpc>
+                <a:spcPct val="150000"/>
+              </a:lnSpc>
+            </a:pPr>
+            <a:r>
+              <a:rPr lang="en-US" altLang="zh-TW" sz="1100" dirty="0">
+                <a:latin typeface="Microsoft JhengHei UI" panose="020B0604030504040204" pitchFamily="34" charset="-120"/>
+                <a:ea typeface="Microsoft JhengHei UI" panose="020B0604030504040204" pitchFamily="34" charset="-120"/>
+              </a:rPr>
+              <a:t>https://public.tableau.com/views/GlobalHotelsandResortsRevenueAnalysis-CancellationAnalysis/CancelTypeRatioAnalysis?:language=en-US&amp;:sid=&amp;:redirect=auth&amp;:display_count=n&amp;:origin=viz_share_link</a:t>
+            </a:r>
           </a:p>
         </p:txBody>
       </p:sp>

</xml_diff>